<commit_message>
Rework the HTTP and API lecture
</commit_message>
<xml_diff>
--- a/presentations/02-skriptovanie-automatizacia.en.pptx
+++ b/presentations/02-skriptovanie-automatizacia.en.pptx
@@ -4200,7 +4200,7 @@
                 <a:ea typeface="Consolas" pitchFamily="34" charset="-122"/>
                 <a:cs typeface="Consolas" pitchFamily="34" charset="-120"/>
               </a:rPr>
-              <a:t>LECTURE 01</a:t>
+              <a:t>LECTURE 02</a:t>
             </a:r>
             <a:endParaRPr lang="en-US" sz="900" dirty="0"/>
           </a:p>
@@ -4574,7 +4574,7 @@
                 <a:ea typeface="Consolas" pitchFamily="34" charset="-122"/>
                 <a:cs typeface="Consolas" pitchFamily="34" charset="-120"/>
               </a:rPr>
-              <a:t>LECTURE 01</a:t>
+              <a:t>LECTURE 02</a:t>
             </a:r>
             <a:endParaRPr lang="en-US" sz="900" dirty="0"/>
           </a:p>
@@ -5054,7 +5054,7 @@
                 <a:ea typeface="Consolas" pitchFamily="34" charset="-122"/>
                 <a:cs typeface="Consolas" pitchFamily="34" charset="-120"/>
               </a:rPr>
-              <a:t>LECTURE 01</a:t>
+              <a:t>LECTURE 02</a:t>
             </a:r>
             <a:endParaRPr lang="en-US" sz="900" dirty="0"/>
           </a:p>
@@ -5545,7 +5545,7 @@
                 <a:ea typeface="Consolas" pitchFamily="34" charset="-122"/>
                 <a:cs typeface="Consolas" pitchFamily="34" charset="-120"/>
               </a:rPr>
-              <a:t>LECTURE 01</a:t>
+              <a:t>LECTURE 02</a:t>
             </a:r>
             <a:endParaRPr lang="en-US" sz="900" dirty="0"/>
           </a:p>
@@ -6065,7 +6065,7 @@
                 <a:ea typeface="Consolas" pitchFamily="34" charset="-122"/>
                 <a:cs typeface="Consolas" pitchFamily="34" charset="-120"/>
               </a:rPr>
-              <a:t>LECTURE 01</a:t>
+              <a:t>LECTURE 02</a:t>
             </a:r>
             <a:endParaRPr lang="en-US" sz="900" dirty="0"/>
           </a:p>
@@ -6428,7 +6428,7 @@
                 <a:ea typeface="Consolas" pitchFamily="34" charset="-122"/>
                 <a:cs typeface="Consolas" pitchFamily="34" charset="-120"/>
               </a:rPr>
-              <a:t>LECTURE 01</a:t>
+              <a:t>LECTURE 02</a:t>
             </a:r>
             <a:endParaRPr lang="en-US" sz="900" dirty="0"/>
           </a:p>
@@ -6925,7 +6925,7 @@
                 <a:ea typeface="Consolas" pitchFamily="34" charset="-122"/>
                 <a:cs typeface="Consolas" pitchFamily="34" charset="-120"/>
               </a:rPr>
-              <a:t>LECTURE 01</a:t>
+              <a:t>LECTURE 02</a:t>
             </a:r>
             <a:endParaRPr lang="en-US" sz="900" dirty="0"/>
           </a:p>
@@ -7383,7 +7383,7 @@
                 <a:ea typeface="Consolas" pitchFamily="34" charset="-122"/>
                 <a:cs typeface="Consolas" pitchFamily="34" charset="-120"/>
               </a:rPr>
-              <a:t>LECTURE 01</a:t>
+              <a:t>LECTURE 02</a:t>
             </a:r>
             <a:endParaRPr lang="en-US" sz="900" dirty="0"/>
           </a:p>
@@ -7757,7 +7757,7 @@
                 <a:ea typeface="Consolas" pitchFamily="34" charset="-122"/>
                 <a:cs typeface="Consolas" pitchFamily="34" charset="-120"/>
               </a:rPr>
-              <a:t>LECTURE 01</a:t>
+              <a:t>LECTURE 02</a:t>
             </a:r>
             <a:endParaRPr lang="en-US" sz="900" dirty="0"/>
           </a:p>
@@ -8371,7 +8371,7 @@
                 <a:ea typeface="Consolas" pitchFamily="34" charset="-122"/>
                 <a:cs typeface="Consolas" pitchFamily="34" charset="-120"/>
               </a:rPr>
-              <a:t>LECTURE 01</a:t>
+              <a:t>LECTURE 02</a:t>
             </a:r>
             <a:endParaRPr lang="en-US" sz="900" dirty="0"/>
           </a:p>
@@ -8919,7 +8919,7 @@
                 <a:ea typeface="Consolas" pitchFamily="34" charset="-122"/>
                 <a:cs typeface="Consolas" pitchFamily="34" charset="-120"/>
               </a:rPr>
-              <a:t>LECTURE 01</a:t>
+              <a:t>LECTURE 02</a:t>
             </a:r>
             <a:endParaRPr lang="en-US" sz="900" dirty="0"/>
           </a:p>
@@ -9282,7 +9282,7 @@
                 <a:ea typeface="Consolas" pitchFamily="34" charset="-122"/>
                 <a:cs typeface="Consolas" pitchFamily="34" charset="-120"/>
               </a:rPr>
-              <a:t>LECTURE 01</a:t>
+              <a:t>LECTURE 02</a:t>
             </a:r>
             <a:endParaRPr lang="en-US" sz="900" dirty="0"/>
           </a:p>
@@ -9813,7 +9813,7 @@
                 <a:ea typeface="Consolas" pitchFamily="34" charset="-122"/>
                 <a:cs typeface="Consolas" pitchFamily="34" charset="-120"/>
               </a:rPr>
-              <a:t>LECTURE 01</a:t>
+              <a:t>LECTURE 02</a:t>
             </a:r>
             <a:endParaRPr lang="en-US" sz="900" dirty="0"/>
           </a:p>
@@ -10187,7 +10187,7 @@
                 <a:ea typeface="Consolas" pitchFamily="34" charset="-122"/>
                 <a:cs typeface="Consolas" pitchFamily="34" charset="-120"/>
               </a:rPr>
-              <a:t>LECTURE 01</a:t>
+              <a:t>LECTURE 02</a:t>
             </a:r>
             <a:endParaRPr lang="en-US" sz="900" dirty="0"/>
           </a:p>
@@ -10842,7 +10842,7 @@
                 <a:ea typeface="Consolas" pitchFamily="34" charset="-122"/>
                 <a:cs typeface="Consolas" pitchFamily="34" charset="-120"/>
               </a:rPr>
-              <a:t>LECTURE 01</a:t>
+              <a:t>LECTURE 02</a:t>
             </a:r>
             <a:endParaRPr lang="en-US" sz="900" dirty="0"/>
           </a:p>
@@ -11345,7 +11345,7 @@
                 <a:ea typeface="Consolas" pitchFamily="34" charset="-122"/>
                 <a:cs typeface="Consolas" pitchFamily="34" charset="-120"/>
               </a:rPr>
-              <a:t>LECTURE 01</a:t>
+              <a:t>LECTURE 02</a:t>
             </a:r>
             <a:endParaRPr lang="en-US" sz="900" dirty="0"/>
           </a:p>
@@ -11859,7 +11859,7 @@
                 <a:ea typeface="Consolas" pitchFamily="34" charset="-122"/>
                 <a:cs typeface="Consolas" pitchFamily="34" charset="-120"/>
               </a:rPr>
-              <a:t>LECTURE 01</a:t>
+              <a:t>LECTURE 02</a:t>
             </a:r>
             <a:endParaRPr lang="en-US" sz="900" dirty="0"/>
           </a:p>
@@ -12414,7 +12414,7 @@
                 <a:ea typeface="Consolas" pitchFamily="34" charset="-122"/>
                 <a:cs typeface="Consolas" pitchFamily="34" charset="-120"/>
               </a:rPr>
-              <a:t>LECTURE 01</a:t>
+              <a:t>LECTURE 02</a:t>
             </a:r>
             <a:endParaRPr lang="en-US" sz="900" dirty="0"/>
           </a:p>
@@ -12911,7 +12911,7 @@
                 <a:ea typeface="Consolas" pitchFamily="34" charset="-122"/>
                 <a:cs typeface="Consolas" pitchFamily="34" charset="-120"/>
               </a:rPr>
-              <a:t>LECTURE 01</a:t>
+              <a:t>LECTURE 02</a:t>
             </a:r>
             <a:endParaRPr lang="en-US" sz="900" dirty="0"/>
           </a:p>
@@ -13285,7 +13285,7 @@
                 <a:ea typeface="Consolas" pitchFamily="34" charset="-122"/>
                 <a:cs typeface="Consolas" pitchFamily="34" charset="-120"/>
               </a:rPr>
-              <a:t>LECTURE 01</a:t>
+              <a:t>LECTURE 02</a:t>
             </a:r>
             <a:endParaRPr lang="en-US" sz="900" dirty="0"/>
           </a:p>
@@ -13799,7 +13799,7 @@
                 <a:ea typeface="Consolas" pitchFamily="34" charset="-122"/>
                 <a:cs typeface="Consolas" pitchFamily="34" charset="-120"/>
               </a:rPr>
-              <a:t>LECTURE 01</a:t>
+              <a:t>LECTURE 02</a:t>
             </a:r>
             <a:endParaRPr lang="en-US" sz="900" dirty="0"/>
           </a:p>
@@ -14296,7 +14296,7 @@
                 <a:ea typeface="Consolas" pitchFamily="34" charset="-122"/>
                 <a:cs typeface="Consolas" pitchFamily="34" charset="-120"/>
               </a:rPr>
-              <a:t>LECTURE 01</a:t>
+              <a:t>LECTURE 02</a:t>
             </a:r>
             <a:endParaRPr lang="en-US" sz="900" dirty="0"/>
           </a:p>
@@ -14851,7 +14851,7 @@
                 <a:ea typeface="Consolas" pitchFamily="34" charset="-122"/>
                 <a:cs typeface="Consolas" pitchFamily="34" charset="-120"/>
               </a:rPr>
-              <a:t>LECTURE 01</a:t>
+              <a:t>LECTURE 02</a:t>
             </a:r>
             <a:endParaRPr lang="en-US" sz="900" dirty="0"/>
           </a:p>
@@ -15399,7 +15399,7 @@
                 <a:ea typeface="Consolas" pitchFamily="34" charset="-122"/>
                 <a:cs typeface="Consolas" pitchFamily="34" charset="-120"/>
               </a:rPr>
-              <a:t>LECTURE 01</a:t>
+              <a:t>LECTURE 02</a:t>
             </a:r>
             <a:endParaRPr lang="en-US" sz="900" dirty="0"/>
           </a:p>
@@ -15762,7 +15762,7 @@
                 <a:ea typeface="Consolas" pitchFamily="34" charset="-122"/>
                 <a:cs typeface="Consolas" pitchFamily="34" charset="-120"/>
               </a:rPr>
-              <a:t>LECTURE 01</a:t>
+              <a:t>LECTURE 02</a:t>
             </a:r>
             <a:endParaRPr lang="en-US" sz="900" dirty="0"/>
           </a:p>
@@ -16287,7 +16287,7 @@
                 <a:ea typeface="Consolas" pitchFamily="34" charset="-122"/>
                 <a:cs typeface="Consolas" pitchFamily="34" charset="-120"/>
               </a:rPr>
-              <a:t>LECTURE 01</a:t>
+              <a:t>LECTURE 02</a:t>
             </a:r>
             <a:endParaRPr lang="en-US" sz="900" dirty="0"/>
           </a:p>
@@ -16937,7 +16937,7 @@
                 <a:ea typeface="Consolas" pitchFamily="34" charset="-122"/>
                 <a:cs typeface="Consolas" pitchFamily="34" charset="-120"/>
               </a:rPr>
-              <a:t>LECTURE 01</a:t>
+              <a:t>LECTURE 02</a:t>
             </a:r>
             <a:endParaRPr lang="en-US" sz="900" dirty="0"/>
           </a:p>
@@ -17323,7 +17323,7 @@
                 <a:ea typeface="Consolas" pitchFamily="34" charset="-122"/>
                 <a:cs typeface="Consolas" pitchFamily="34" charset="-120"/>
               </a:rPr>
-              <a:t>LECTURE 01</a:t>
+              <a:t>LECTURE 02</a:t>
             </a:r>
             <a:endParaRPr lang="en-US" sz="900" dirty="0"/>
           </a:p>
@@ -17781,7 +17781,7 @@
                 <a:ea typeface="Consolas" pitchFamily="34" charset="-122"/>
                 <a:cs typeface="Consolas" pitchFamily="34" charset="-120"/>
               </a:rPr>
-              <a:t>LECTURE 01</a:t>
+              <a:t>LECTURE 02</a:t>
             </a:r>
             <a:endParaRPr lang="en-US" sz="900" dirty="0"/>
           </a:p>
@@ -18155,7 +18155,7 @@
                 <a:ea typeface="Consolas" pitchFamily="34" charset="-122"/>
                 <a:cs typeface="Consolas" pitchFamily="34" charset="-120"/>
               </a:rPr>
-              <a:t>LECTURE 01</a:t>
+              <a:t>LECTURE 02</a:t>
             </a:r>
             <a:endParaRPr lang="en-US" sz="900" dirty="0"/>
           </a:p>
@@ -18810,7 +18810,7 @@
                 <a:ea typeface="Consolas" pitchFamily="34" charset="-122"/>
                 <a:cs typeface="Consolas" pitchFamily="34" charset="-120"/>
               </a:rPr>
-              <a:t>LECTURE 01</a:t>
+              <a:t>LECTURE 02</a:t>
             </a:r>
             <a:endParaRPr lang="en-US" sz="900" dirty="0"/>
           </a:p>
@@ -19324,7 +19324,7 @@
                 <a:ea typeface="Consolas" pitchFamily="34" charset="-122"/>
                 <a:cs typeface="Consolas" pitchFamily="34" charset="-120"/>
               </a:rPr>
-              <a:t>LECTURE 01</a:t>
+              <a:t>LECTURE 02</a:t>
             </a:r>
             <a:endParaRPr lang="en-US" sz="900" dirty="0"/>
           </a:p>

</xml_diff>